<commit_message>
Submission deck: team name and member emails
</commit_message>
<xml_diff>
--- a/SRMIST_Doomed_Submission.pptx
+++ b/SRMIST_Doomed_Submission.pptx
@@ -13175,7 +13175,31 @@
                 <a:cs typeface="Calibri" panose="020F0502020204030204"/>
                 <a:sym typeface="Calibri" panose="020F0502020204030204"/>
               </a:rPr>
-              <a:t>Team Name - Doomed</a:t>
+              <a:t>Team Name -</a:t>
+            </a:r>
+            <a:r>
+              <a:rPr lang="en-IN" altLang="en-US" sz="1600" b="0" i="0" u="none" strike="noStrike" cap="none">
+                <a:solidFill>
+                  <a:srgbClr val="63637E"/>
+                </a:solidFill>
+                <a:latin typeface="Calibri" panose="020F0502020204030204"/>
+                <a:ea typeface="Calibri" panose="020F0502020204030204"/>
+                <a:cs typeface="Calibri" panose="020F0502020204030204"/>
+                <a:sym typeface="Calibri" panose="020F0502020204030204"/>
+              </a:rPr>
+              <a:t> Team</a:t>
+            </a:r>
+            <a:r>
+              <a:rPr lang="en-US" sz="1600" b="0" i="0" u="none" strike="noStrike" cap="none">
+                <a:solidFill>
+                  <a:srgbClr val="63637E"/>
+                </a:solidFill>
+                <a:latin typeface="Calibri" panose="020F0502020204030204"/>
+                <a:ea typeface="Calibri" panose="020F0502020204030204"/>
+                <a:cs typeface="Calibri" panose="020F0502020204030204"/>
+                <a:sym typeface="Calibri" panose="020F0502020204030204"/>
+              </a:rPr>
+              <a:t> Doomed</a:t>
             </a:r>
             <a:endParaRPr lang="en-US" sz="1600" b="0" i="0" u="none" strike="noStrike" cap="none">
               <a:solidFill>

</xml_diff>